<commit_message>
Update title slide to match original template design
- 左寄せレイアウトに変更
- 備考行（グレー + 赤字下線ハイライト）を追加
- メインタイトル行: サブタイトル(24pt) + タイトル(32pt, ゴールド下線)
- 関数シグネチャ: addTitleSlide(pres, title, subtitle, noteText, noteHighlight)
- README.md, AGENTS.md のサンプルコードを更新

Co-Authored-By: Claude Opus 4.5 <noreply@anthropic.com>
</commit_message>
<xml_diff>
--- a/examples/how-to-use.pptx
+++ b/examples/how-to-use.pptx
@@ -2389,29 +2389,40 @@
         </p:nvSpPr>
         <p:spPr>
           <a:xfrm>
-            <a:off x="731520" y="2560320"/>
-            <a:ext cx="10728655" cy="914400"/>
-          </a:xfrm>
-          <a:prstGeom prst="rect">
-            <a:avLst/>
-          </a:prstGeom>
-          <a:noFill/>
-          <a:ln/>
-        </p:spPr>
-        <p:txBody>
-          <a:bodyPr wrap="square" rtlCol="0" anchor="ctr"/>
-          <a:lstStyle/>
-          <a:p>
-            <a:pPr algn="ctr" indent="0" marL="0">
-              <a:lnSpc>
-                <a:spcPts val="3600"/>
-              </a:lnSpc>
-              <a:buNone/>
-            </a:pPr>
-            <a:r>
-              <a:rPr lang="en-US" sz="3200" b="1" dirty="0">
-                <a:solidFill>
-                  <a:srgbClr val="454545"/>
+            <a:off x="621792" y="2871216"/>
+            <a:ext cx="7315200" cy="320040"/>
+          </a:xfrm>
+          <a:prstGeom prst="rect">
+            <a:avLst/>
+          </a:prstGeom>
+          <a:noFill/>
+          <a:ln/>
+        </p:spPr>
+        <p:txBody>
+          <a:bodyPr wrap="square" rtlCol="0" anchor="ctr"/>
+          <a:lstStyle/>
+          <a:p>
+            <a:pPr indent="0" marL="0">
+              <a:buNone/>
+            </a:pPr>
+            <a:r>
+              <a:rPr lang="en-US" sz="1400" b="1" dirty="0">
+                <a:solidFill>
+                  <a:srgbClr val="7F7F7F"/>
+                </a:solidFill>
+                <a:latin typeface="メイリオ" pitchFamily="34" charset="0"/>
+                <a:ea typeface="メイリオ" pitchFamily="34" charset="-122"/>
+                <a:cs typeface="メイリオ" pitchFamily="34" charset="-120"/>
+              </a:rPr>
+              <a:t>スライド自動生成システム - </a:t>
+            </a:r>
+            <a:pPr indent="0" marL="0">
+              <a:buNone/>
+            </a:pPr>
+            <a:r>
+              <a:rPr lang="en-US" sz="1400" b="1" dirty="0">
+                <a:solidFill>
+                  <a:srgbClr val="EA4545"/>
                 </a:solidFill>
                 <a:uFill>
                   <a:solidFill>
@@ -2422,9 +2433,9 @@
                 <a:ea typeface="メイリオ" pitchFamily="34" charset="-122"/>
                 <a:cs typeface="メイリオ" pitchFamily="34" charset="-120"/>
               </a:rPr>
-              <a:t>PptxGenJS テンプレート</a:t>
-            </a:r>
-            <a:endParaRPr lang="en-US" sz="3200" dirty="0"/>
+              <a:t>SBI Traceability</a:t>
+            </a:r>
+            <a:endParaRPr lang="en-US" sz="1400" dirty="0"/>
           </a:p>
         </p:txBody>
       </p:sp>
@@ -2436,79 +2447,65 @@
         </p:nvSpPr>
         <p:spPr>
           <a:xfrm>
-            <a:off x="731520" y="3657600"/>
-            <a:ext cx="10728655" cy="548640"/>
-          </a:xfrm>
-          <a:prstGeom prst="rect">
-            <a:avLst/>
-          </a:prstGeom>
-          <a:noFill/>
-          <a:ln/>
-        </p:spPr>
-        <p:txBody>
-          <a:bodyPr wrap="square" rtlCol="0" anchor="ctr"/>
-          <a:lstStyle/>
-          <a:p>
-            <a:pPr algn="ctr" indent="0" marL="0">
-              <a:buNone/>
-            </a:pPr>
-            <a:r>
-              <a:rPr lang="en-US" sz="2000" dirty="0">
-                <a:solidFill>
-                  <a:srgbClr val="535353"/>
+            <a:off x="621792" y="3182112"/>
+            <a:ext cx="9144000" cy="731520"/>
+          </a:xfrm>
+          <a:prstGeom prst="rect">
+            <a:avLst/>
+          </a:prstGeom>
+          <a:noFill/>
+          <a:ln/>
+        </p:spPr>
+        <p:txBody>
+          <a:bodyPr wrap="square" rtlCol="0" anchor="ctr"/>
+          <a:lstStyle/>
+          <a:p>
+            <a:pPr indent="0" marL="0">
+              <a:lnSpc>
+                <a:spcPts val="3800"/>
+              </a:lnSpc>
+              <a:buNone/>
+            </a:pPr>
+            <a:r>
+              <a:rPr lang="en-US" sz="2400" b="1" dirty="0">
+                <a:solidFill>
+                  <a:srgbClr val="454545"/>
                 </a:solidFill>
                 <a:latin typeface="メイリオ" pitchFamily="34" charset="0"/>
                 <a:ea typeface="メイリオ" pitchFamily="34" charset="-122"/>
                 <a:cs typeface="メイリオ" pitchFamily="34" charset="-120"/>
               </a:rPr>
-              <a:t>AIを活用したスライド自動生成システム</a:t>
-            </a:r>
-            <a:endParaRPr lang="en-US" sz="2000" dirty="0"/>
-          </a:p>
-        </p:txBody>
-      </p:sp>
-      <p:sp>
-        <p:nvSpPr>
-          <p:cNvPr id="4" name="Text 2"/>
-          <p:cNvSpPr/>
-          <p:nvPr/>
-        </p:nvSpPr>
-        <p:spPr>
-          <a:xfrm>
-            <a:off x="731520" y="5029200"/>
-            <a:ext cx="10728655" cy="365760"/>
-          </a:xfrm>
-          <a:prstGeom prst="rect">
-            <a:avLst/>
-          </a:prstGeom>
-          <a:noFill/>
-          <a:ln/>
-        </p:spPr>
-        <p:txBody>
-          <a:bodyPr wrap="square" rtlCol="0" anchor="ctr"/>
-          <a:lstStyle/>
-          <a:p>
-            <a:pPr algn="ctr" indent="0" marL="0">
-              <a:buNone/>
-            </a:pPr>
-            <a:r>
-              <a:rPr lang="en-US" sz="1400" dirty="0">
-                <a:solidFill>
-                  <a:srgbClr val="7F7F7F"/>
-                </a:solidFill>
+              <a:t>AIを活用した  </a:t>
+            </a:r>
+            <a:pPr indent="0" marL="0">
+              <a:lnSpc>
+                <a:spcPts val="3800"/>
+              </a:lnSpc>
+              <a:buNone/>
+            </a:pPr>
+            <a:r>
+              <a:rPr lang="en-US" sz="3200" b="1" dirty="0">
+                <a:solidFill>
+                  <a:srgbClr val="454545"/>
+                </a:solidFill>
+                <a:uFill>
+                  <a:solidFill>
+                    <a:srgbClr val="CBC269"/>
+                  </a:solidFill>
+                </a:uFill>
                 <a:latin typeface="メイリオ" pitchFamily="34" charset="0"/>
                 <a:ea typeface="メイリオ" pitchFamily="34" charset="-122"/>
                 <a:cs typeface="メイリオ" pitchFamily="34" charset="-120"/>
               </a:rPr>
-              <a:t>SBI Traceability  |  2024年</a:t>
-            </a:r>
-            <a:endParaRPr lang="en-US" sz="1400" dirty="0"/>
-          </a:p>
-        </p:txBody>
-      </p:sp>
-      <p:sp>
-        <p:nvSpPr>
-          <p:cNvPr id="5" name="Text 3"/>
+              <a:t>PptxGenJS テンプレート</a:t>
+            </a:r>
+            <a:endParaRPr lang="en-US" sz="2400" dirty="0"/>
+          </a:p>
+        </p:txBody>
+      </p:sp>
+      <p:sp>
+        <p:nvSpPr>
+          <p:cNvPr id="4" name="Text 2"/>
           <p:cNvSpPr/>
           <p:nvPr/>
         </p:nvSpPr>
@@ -2547,7 +2544,7 @@
       </p:sp>
       <p:sp>
         <p:nvSpPr>
-          <p:cNvPr id="6" name="Text 4"/>
+          <p:cNvPr id="5" name="Text 3"/>
           <p:cNvSpPr/>
           <p:nvPr/>
         </p:nvSpPr>

</xml_diff>